<commit_message>
docs(pitch): add M. A. Mukhamedyarov photo to the title and team slides
Co-Authored-By: Claude Opus 5.5 <noreply@anthropic.com>
Claude-Session: https://claude.ai/code/session_01DiRwsPAPzHdoAzcdYEtMLh
</commit_message>
<xml_diff>
--- a/deliverables/pitch/ION-ITpark-2026.pptx
+++ b/deliverables/pitch/ION-ITpark-2026.pptx
@@ -126,7 +126,7 @@
   <p:extLst>
     <p:ext uri="{521415D9-36F7-43E2-AB2F-B90AF26B5E84}">
       <p14:sectionLst xmlns:p14="http://schemas.microsoft.com/office/powerpoint/2010/main">
-        <p14:section name="Проект" id="{c22da4f2-a7cc-6423-763b-20b54b5c21fe}">
+        <p14:section name="Проект" id="{6e7bd0df-ca54-d38d-e600-70c1133b34b3}">
           <p14:sldIdLst>
             <p14:sldId id="256"/>
             <p14:sldId id="257"/>
@@ -134,21 +134,21 @@
             <p14:sldId id="259"/>
           </p14:sldIdLst>
         </p14:section>
-        <p14:section name="Продукт" id="{40635b52-47d0-b397-146d-27bb1c838936}">
+        <p14:section name="Продукт" id="{17da2006-f714-9197-53c5-b3138c02333c}">
           <p14:sldIdLst>
             <p14:sldId id="260"/>
             <p14:sldId id="261"/>
             <p14:sldId id="262"/>
           </p14:sldIdLst>
         </p14:section>
-        <p14:section name="Рынок" id="{71233aad-7cfd-c7fe-4ee0-1af401367134}">
+        <p14:section name="Рынок" id="{4b9c001c-6e15-2917-5c62-6e210d9179d8}">
           <p14:sldIdLst>
             <p14:sldId id="263"/>
             <p14:sldId id="264"/>
             <p14:sldId id="265"/>
           </p14:sldIdLst>
         </p14:section>
-        <p14:section name="План" id="{bfd96cf8-8bea-90a6-750c-813f2e4564ce}">
+        <p14:section name="План" id="{4942490b-9cde-e7ec-94bf-d096b2811c5e}">
           <p14:sldIdLst>
             <p14:sldId id="266"/>
             <p14:sldId id="267"/>
@@ -156,14 +156,14 @@
             <p14:sldId id="269"/>
           </p14:sldIdLst>
         </p14:section>
-        <p14:section name="Команда и запрос" id="{def592e4-d1ef-ddf4-b0ba-d44a7c409ae4}">
+        <p14:section name="Команда и запрос" id="{dccc4da4-979e-8349-6228-66dec6528018}">
           <p14:sldIdLst>
             <p14:sldId id="270"/>
             <p14:sldId id="271"/>
             <p14:sldId id="272"/>
           </p14:sldIdLst>
         </p14:section>
-        <p14:section name="Приложение" id="{af040f5e-604f-3404-a994-9f15c4185103}">
+        <p14:section name="Приложение" id="{b798cfba-7c42-4d4e-5971-b9d40054f6ad}">
           <p14:sldIdLst>
             <p14:sldId id="273"/>
             <p14:sldId id="274"/>
@@ -3075,146 +3075,9 @@
           </a:p>
         </p:txBody>
       </p:sp>
-      <p:sp>
-        <p:nvSpPr>
-          <p:cNvPr id="7" name="Shape 4"/>
-          <p:cNvSpPr/>
-          <p:nvPr/>
-        </p:nvSpPr>
-        <p:spPr>
-          <a:xfrm>
-            <a:off x="548640" y="4800600"/>
-            <a:ext cx="713232" cy="713232"/>
-          </a:xfrm>
-          <a:prstGeom prst="ellipse">
-            <a:avLst/>
-          </a:prstGeom>
-          <a:solidFill>
-            <a:srgbClr val="ECEEFA"/>
-          </a:solidFill>
-          <a:ln/>
-        </p:spPr>
-      </p:sp>
-      <p:sp>
-        <p:nvSpPr>
-          <p:cNvPr id="8" name="Text 5"/>
-          <p:cNvSpPr txBox="1"/>
-          <p:nvPr/>
-        </p:nvSpPr>
-        <p:spPr>
-          <a:xfrm>
-            <a:off x="548640" y="4800600"/>
-            <a:ext cx="713232" cy="713232"/>
-          </a:xfrm>
-          <a:prstGeom prst="rect">
-            <a:avLst/>
-          </a:prstGeom>
-          <a:noFill/>
-          <a:ln/>
-        </p:spPr>
-        <p:txBody>
-          <a:bodyPr wrap="square" lIns="0" tIns="0" rIns="0" bIns="0" rtlCol="0" anchor="ctr"/>
-          <a:lstStyle/>
-          <a:p>
-            <a:pPr algn="ctr" indent="0" marL="0">
-              <a:buNone/>
-            </a:pPr>
-            <a:r>
-              <a:rPr lang="en-US" sz="1800" b="1" dirty="0">
-                <a:solidFill>
-                  <a:srgbClr val="1C2C66"/>
-                </a:solidFill>
-                <a:latin typeface="Times New Roman" pitchFamily="34" charset="0"/>
-                <a:ea typeface="Times New Roman" pitchFamily="34" charset="-122"/>
-                <a:cs typeface="Times New Roman" pitchFamily="34" charset="-120"/>
-              </a:rPr>
-              <a:t>ММ</a:t>
-            </a:r>
-            <a:endParaRPr lang="en-US" sz="1800" dirty="0"/>
-          </a:p>
-        </p:txBody>
-      </p:sp>
-      <p:sp>
-        <p:nvSpPr>
-          <p:cNvPr id="9" name="Text 6"/>
-          <p:cNvSpPr txBox="1"/>
-          <p:nvPr/>
-        </p:nvSpPr>
-        <p:spPr>
-          <a:xfrm>
-            <a:off x="1417320" y="4873752"/>
-            <a:ext cx="2331720" cy="292608"/>
-          </a:xfrm>
-          <a:prstGeom prst="rect">
-            <a:avLst/>
-          </a:prstGeom>
-          <a:noFill/>
-          <a:ln/>
-        </p:spPr>
-        <p:txBody>
-          <a:bodyPr wrap="square" lIns="0" tIns="0" rIns="0" bIns="0" rtlCol="0" anchor="t"/>
-          <a:lstStyle/>
-          <a:p>
-            <a:pPr indent="0" marL="0">
-              <a:buNone/>
-            </a:pPr>
-            <a:r>
-              <a:rPr lang="en-US" sz="1400" b="1" dirty="0">
-                <a:solidFill>
-                  <a:srgbClr val="1F1D1A"/>
-                </a:solidFill>
-                <a:latin typeface="Calibri" pitchFamily="34" charset="0"/>
-                <a:ea typeface="Calibri" pitchFamily="34" charset="-122"/>
-                <a:cs typeface="Calibri" pitchFamily="34" charset="-120"/>
-              </a:rPr>
-              <a:t>Марат Мухамедьяров</a:t>
-            </a:r>
-            <a:endParaRPr lang="en-US" sz="1400" dirty="0"/>
-          </a:p>
-        </p:txBody>
-      </p:sp>
-      <p:sp>
-        <p:nvSpPr>
-          <p:cNvPr id="10" name="Text 7"/>
-          <p:cNvSpPr txBox="1"/>
-          <p:nvPr/>
-        </p:nvSpPr>
-        <p:spPr>
-          <a:xfrm>
-            <a:off x="1417320" y="5166360"/>
-            <a:ext cx="2331720" cy="292608"/>
-          </a:xfrm>
-          <a:prstGeom prst="rect">
-            <a:avLst/>
-          </a:prstGeom>
-          <a:noFill/>
-          <a:ln/>
-        </p:spPr>
-        <p:txBody>
-          <a:bodyPr wrap="square" lIns="0" tIns="0" rIns="0" bIns="0" rtlCol="0" anchor="t"/>
-          <a:lstStyle/>
-          <a:p>
-            <a:pPr indent="0" marL="0">
-              <a:buNone/>
-            </a:pPr>
-            <a:r>
-              <a:rPr lang="en-US" sz="1200" dirty="0">
-                <a:solidFill>
-                  <a:srgbClr val="5D5A55"/>
-                </a:solidFill>
-                <a:latin typeface="Calibri" pitchFamily="34" charset="0"/>
-                <a:ea typeface="Calibri" pitchFamily="34" charset="-122"/>
-                <a:cs typeface="Calibri" pitchFamily="34" charset="-120"/>
-              </a:rPr>
-              <a:t>д.м.н., профессор, Казанский ГМУ</a:t>
-            </a:r>
-            <a:endParaRPr lang="en-US" sz="1200" dirty="0"/>
-          </a:p>
-        </p:txBody>
-      </p:sp>
       <p:pic>
         <p:nvPicPr>
-          <p:cNvPr id="11" name="Image 1" descr="/home/user/SciBox/deliverables/pitch/assets/azamat-sq.jpg">    </p:cNvPr>
+          <p:cNvPr id="7" name="Image 1" descr="/home/user/SciBox/deliverables/pitch/assets/marat-sq.jpg">    </p:cNvPr>
           <p:cNvPicPr>
             <a:picLocks noChangeAspect="1"/>
           </p:cNvPicPr>
@@ -3227,7 +3090,7 @@
         </p:blipFill>
         <p:spPr>
           <a:xfrm>
-            <a:off x="3840480" y="4800600"/>
+            <a:off x="548640" y="4800600"/>
             <a:ext cx="713232" cy="713232"/>
           </a:xfrm>
           <a:prstGeom prst="ellipse">
@@ -3237,13 +3100,35 @@
       </p:pic>
       <p:sp>
         <p:nvSpPr>
-          <p:cNvPr id="12" name="Text 8"/>
-          <p:cNvSpPr txBox="1"/>
-          <p:nvPr/>
-        </p:nvSpPr>
-        <p:spPr>
-          <a:xfrm>
-            <a:off x="4709160" y="4873752"/>
+          <p:cNvPr id="8" name="Shape 4"/>
+          <p:cNvSpPr/>
+          <p:nvPr/>
+        </p:nvSpPr>
+        <p:spPr>
+          <a:xfrm>
+            <a:off x="548640" y="4800600"/>
+            <a:ext cx="713232" cy="713232"/>
+          </a:xfrm>
+          <a:prstGeom prst="ellipse">
+            <a:avLst/>
+          </a:prstGeom>
+          <a:ln w="15875">
+            <a:solidFill>
+              <a:srgbClr val="E4E1DC"/>
+            </a:solidFill>
+            <a:prstDash val="solid"/>
+          </a:ln>
+        </p:spPr>
+      </p:sp>
+      <p:sp>
+        <p:nvSpPr>
+          <p:cNvPr id="9" name="Text 5"/>
+          <p:cNvSpPr txBox="1"/>
+          <p:nvPr/>
+        </p:nvSpPr>
+        <p:spPr>
+          <a:xfrm>
+            <a:off x="1417320" y="4873752"/>
             <a:ext cx="2331720" cy="292608"/>
           </a:xfrm>
           <a:prstGeom prst="rect">
@@ -3268,7 +3153,7 @@
                 <a:ea typeface="Calibri" pitchFamily="34" charset="-122"/>
                 <a:cs typeface="Calibri" pitchFamily="34" charset="-120"/>
               </a:rPr>
-              <a:t>Азамат Сибгатуллин</a:t>
+              <a:t>Марат Мухамедьяров</a:t>
             </a:r>
             <a:endParaRPr lang="en-US" sz="1400" dirty="0"/>
           </a:p>
@@ -3276,13 +3161,13 @@
       </p:sp>
       <p:sp>
         <p:nvSpPr>
-          <p:cNvPr id="13" name="Text 9"/>
-          <p:cNvSpPr txBox="1"/>
-          <p:nvPr/>
-        </p:nvSpPr>
-        <p:spPr>
-          <a:xfrm>
-            <a:off x="4709160" y="5166360"/>
+          <p:cNvPr id="10" name="Text 6"/>
+          <p:cNvSpPr txBox="1"/>
+          <p:nvPr/>
+        </p:nvSpPr>
+        <p:spPr>
+          <a:xfrm>
+            <a:off x="1417320" y="5166360"/>
             <a:ext cx="2331720" cy="292608"/>
           </a:xfrm>
           <a:prstGeom prst="rect">
@@ -3307,22 +3192,67 @@
                 <a:ea typeface="Calibri" pitchFamily="34" charset="-122"/>
                 <a:cs typeface="Calibri" pitchFamily="34" charset="-120"/>
               </a:rPr>
-              <a:t>разработчик платформы</a:t>
+              <a:t>д.м.н., профессор, Казанский ГМУ</a:t>
             </a:r>
             <a:endParaRPr lang="en-US" sz="1200" dirty="0"/>
           </a:p>
         </p:txBody>
       </p:sp>
-      <p:sp>
-        <p:nvSpPr>
-          <p:cNvPr id="14" name="Text 10"/>
-          <p:cNvSpPr txBox="1"/>
-          <p:nvPr/>
-        </p:nvSpPr>
-        <p:spPr>
-          <a:xfrm>
-            <a:off x="548640" y="6172200"/>
-            <a:ext cx="2743200" cy="274320"/>
+      <p:pic>
+        <p:nvPicPr>
+          <p:cNvPr id="11" name="Image 2" descr="/home/user/SciBox/deliverables/pitch/assets/azamat-sq.jpg">    </p:cNvPr>
+          <p:cNvPicPr>
+            <a:picLocks noChangeAspect="1"/>
+          </p:cNvPicPr>
+          <p:nvPr/>
+        </p:nvPicPr>
+        <p:blipFill>
+          <a:blip r:embed="rId3"/>
+          <a:srcRect l="0" r="0" t="0" b="0"/>
+          <a:stretch/>
+        </p:blipFill>
+        <p:spPr>
+          <a:xfrm>
+            <a:off x="3840480" y="4800600"/>
+            <a:ext cx="713232" cy="713232"/>
+          </a:xfrm>
+          <a:prstGeom prst="ellipse">
+            <a:avLst/>
+          </a:prstGeom>
+        </p:spPr>
+      </p:pic>
+      <p:sp>
+        <p:nvSpPr>
+          <p:cNvPr id="12" name="Shape 7"/>
+          <p:cNvSpPr/>
+          <p:nvPr/>
+        </p:nvSpPr>
+        <p:spPr>
+          <a:xfrm>
+            <a:off x="3840480" y="4800600"/>
+            <a:ext cx="713232" cy="713232"/>
+          </a:xfrm>
+          <a:prstGeom prst="ellipse">
+            <a:avLst/>
+          </a:prstGeom>
+          <a:ln w="15875">
+            <a:solidFill>
+              <a:srgbClr val="E4E1DC"/>
+            </a:solidFill>
+            <a:prstDash val="solid"/>
+          </a:ln>
+        </p:spPr>
+      </p:sp>
+      <p:sp>
+        <p:nvSpPr>
+          <p:cNvPr id="13" name="Text 8"/>
+          <p:cNvSpPr txBox="1"/>
+          <p:nvPr/>
+        </p:nvSpPr>
+        <p:spPr>
+          <a:xfrm>
+            <a:off x="4709160" y="4873752"/>
+            <a:ext cx="2331720" cy="292608"/>
           </a:xfrm>
           <a:prstGeom prst="rect">
             <a:avLst/>
@@ -3338,14 +3268,92 @@
               <a:buNone/>
             </a:pPr>
             <a:r>
-              <a:rPr lang="en-US" sz="1100" dirty="0">
-                <a:solidFill>
-                  <a:srgbClr val="85807A"/>
+              <a:rPr lang="en-US" sz="1400" b="1" dirty="0">
+                <a:solidFill>
+                  <a:srgbClr val="1F1D1A"/>
                 </a:solidFill>
                 <a:latin typeface="Calibri" pitchFamily="34" charset="0"/>
                 <a:ea typeface="Calibri" pitchFamily="34" charset="-122"/>
                 <a:cs typeface="Calibri" pitchFamily="34" charset="-120"/>
               </a:rPr>
+              <a:t>Азамат Сибгатуллин</a:t>
+            </a:r>
+            <a:endParaRPr lang="en-US" sz="1400" dirty="0"/>
+          </a:p>
+        </p:txBody>
+      </p:sp>
+      <p:sp>
+        <p:nvSpPr>
+          <p:cNvPr id="14" name="Text 9"/>
+          <p:cNvSpPr txBox="1"/>
+          <p:nvPr/>
+        </p:nvSpPr>
+        <p:spPr>
+          <a:xfrm>
+            <a:off x="4709160" y="5166360"/>
+            <a:ext cx="2331720" cy="292608"/>
+          </a:xfrm>
+          <a:prstGeom prst="rect">
+            <a:avLst/>
+          </a:prstGeom>
+          <a:noFill/>
+          <a:ln/>
+        </p:spPr>
+        <p:txBody>
+          <a:bodyPr wrap="square" lIns="0" tIns="0" rIns="0" bIns="0" rtlCol="0" anchor="t"/>
+          <a:lstStyle/>
+          <a:p>
+            <a:pPr indent="0" marL="0">
+              <a:buNone/>
+            </a:pPr>
+            <a:r>
+              <a:rPr lang="en-US" sz="1200" dirty="0">
+                <a:solidFill>
+                  <a:srgbClr val="5D5A55"/>
+                </a:solidFill>
+                <a:latin typeface="Calibri" pitchFamily="34" charset="0"/>
+                <a:ea typeface="Calibri" pitchFamily="34" charset="-122"/>
+                <a:cs typeface="Calibri" pitchFamily="34" charset="-120"/>
+              </a:rPr>
+              <a:t>разработчик платформы</a:t>
+            </a:r>
+            <a:endParaRPr lang="en-US" sz="1200" dirty="0"/>
+          </a:p>
+        </p:txBody>
+      </p:sp>
+      <p:sp>
+        <p:nvSpPr>
+          <p:cNvPr id="15" name="Text 10"/>
+          <p:cNvSpPr txBox="1"/>
+          <p:nvPr/>
+        </p:nvSpPr>
+        <p:spPr>
+          <a:xfrm>
+            <a:off x="548640" y="6172200"/>
+            <a:ext cx="2743200" cy="274320"/>
+          </a:xfrm>
+          <a:prstGeom prst="rect">
+            <a:avLst/>
+          </a:prstGeom>
+          <a:noFill/>
+          <a:ln/>
+        </p:spPr>
+        <p:txBody>
+          <a:bodyPr wrap="square" lIns="0" tIns="0" rIns="0" bIns="0" rtlCol="0" anchor="t"/>
+          <a:lstStyle/>
+          <a:p>
+            <a:pPr indent="0" marL="0">
+              <a:buNone/>
+            </a:pPr>
+            <a:r>
+              <a:rPr lang="en-US" sz="1100" dirty="0">
+                <a:solidFill>
+                  <a:srgbClr val="85807A"/>
+                </a:solidFill>
+                <a:latin typeface="Calibri" pitchFamily="34" charset="0"/>
+                <a:ea typeface="Calibri" pitchFamily="34" charset="-122"/>
+                <a:cs typeface="Calibri" pitchFamily="34" charset="-120"/>
+              </a:rPr>
               <a:t>Казань · 2026</a:t>
             </a:r>
             <a:endParaRPr lang="en-US" sz="1100" dirty="0"/>
@@ -3354,7 +3362,7 @@
       </p:sp>
       <p:sp>
         <p:nvSpPr>
-          <p:cNvPr id="15" name="Shape 11"/>
+          <p:cNvPr id="16" name="Shape 11"/>
           <p:cNvSpPr/>
           <p:nvPr/>
         </p:nvSpPr>
@@ -3374,7 +3382,7 @@
       </p:sp>
       <p:sp>
         <p:nvSpPr>
-          <p:cNvPr id="16" name="Text 12"/>
+          <p:cNvPr id="17" name="Text 12"/>
           <p:cNvSpPr txBox="1"/>
           <p:nvPr/>
         </p:nvSpPr>
@@ -3413,7 +3421,7 @@
       </p:sp>
       <p:sp>
         <p:nvSpPr>
-          <p:cNvPr id="17" name="Shape 13"/>
+          <p:cNvPr id="18" name="Shape 13"/>
           <p:cNvSpPr/>
           <p:nvPr/>
         </p:nvSpPr>
@@ -3438,7 +3446,7 @@
       </p:sp>
       <p:sp>
         <p:nvSpPr>
-          <p:cNvPr id="18" name="Text 14"/>
+          <p:cNvPr id="19" name="Text 14"/>
           <p:cNvSpPr txBox="1"/>
           <p:nvPr/>
         </p:nvSpPr>
@@ -3477,7 +3485,7 @@
       </p:sp>
       <p:sp>
         <p:nvSpPr>
-          <p:cNvPr id="19" name="Text 15"/>
+          <p:cNvPr id="20" name="Text 15"/>
           <p:cNvSpPr txBox="1"/>
           <p:nvPr/>
         </p:nvSpPr>
@@ -3516,7 +3524,7 @@
       </p:sp>
       <p:sp>
         <p:nvSpPr>
-          <p:cNvPr id="20" name="Text 16"/>
+          <p:cNvPr id="21" name="Text 16"/>
           <p:cNvSpPr txBox="1"/>
           <p:nvPr/>
         </p:nvSpPr>
@@ -3555,7 +3563,7 @@
       </p:sp>
       <p:sp>
         <p:nvSpPr>
-          <p:cNvPr id="21" name="Shape 17"/>
+          <p:cNvPr id="22" name="Shape 17"/>
           <p:cNvSpPr/>
           <p:nvPr/>
         </p:nvSpPr>
@@ -3580,7 +3588,7 @@
       </p:sp>
       <p:sp>
         <p:nvSpPr>
-          <p:cNvPr id="22" name="Text 18"/>
+          <p:cNvPr id="23" name="Text 18"/>
           <p:cNvSpPr txBox="1"/>
           <p:nvPr/>
         </p:nvSpPr>
@@ -3619,7 +3627,7 @@
       </p:sp>
       <p:sp>
         <p:nvSpPr>
-          <p:cNvPr id="23" name="Text 19"/>
+          <p:cNvPr id="24" name="Text 19"/>
           <p:cNvSpPr txBox="1"/>
           <p:nvPr/>
         </p:nvSpPr>
@@ -3658,7 +3666,7 @@
       </p:sp>
       <p:sp>
         <p:nvSpPr>
-          <p:cNvPr id="24" name="Text 20"/>
+          <p:cNvPr id="25" name="Text 20"/>
           <p:cNvSpPr txBox="1"/>
           <p:nvPr/>
         </p:nvSpPr>
@@ -3697,7 +3705,7 @@
       </p:sp>
       <p:sp>
         <p:nvSpPr>
-          <p:cNvPr id="25" name="Shape 21"/>
+          <p:cNvPr id="26" name="Shape 21"/>
           <p:cNvSpPr/>
           <p:nvPr/>
         </p:nvSpPr>
@@ -3722,7 +3730,7 @@
       </p:sp>
       <p:sp>
         <p:nvSpPr>
-          <p:cNvPr id="26" name="Text 22"/>
+          <p:cNvPr id="27" name="Text 22"/>
           <p:cNvSpPr txBox="1"/>
           <p:nvPr/>
         </p:nvSpPr>
@@ -3761,7 +3769,7 @@
       </p:sp>
       <p:sp>
         <p:nvSpPr>
-          <p:cNvPr id="27" name="Text 23"/>
+          <p:cNvPr id="28" name="Text 23"/>
           <p:cNvSpPr txBox="1"/>
           <p:nvPr/>
         </p:nvSpPr>
@@ -3800,7 +3808,7 @@
       </p:sp>
       <p:sp>
         <p:nvSpPr>
-          <p:cNvPr id="28" name="Text 24"/>
+          <p:cNvPr id="29" name="Text 24"/>
           <p:cNvSpPr txBox="1"/>
           <p:nvPr/>
         </p:nvSpPr>
@@ -10856,12 +10864,19 @@
           <a:ln/>
         </p:spPr>
       </p:sp>
-      <p:sp>
-        <p:nvSpPr>
-          <p:cNvPr id="6" name="Shape 4"/>
-          <p:cNvSpPr/>
-          <p:nvPr/>
-        </p:nvSpPr>
+      <p:pic>
+        <p:nvPicPr>
+          <p:cNvPr id="6" name="Image 0" descr="/home/user/SciBox/deliverables/pitch/assets/marat.jpg">    </p:cNvPr>
+          <p:cNvPicPr>
+            <a:picLocks noChangeAspect="1"/>
+          </p:cNvPicPr>
+          <p:nvPr/>
+        </p:nvPicPr>
+        <p:blipFill>
+          <a:blip r:embed="rId1"/>
+          <a:srcRect l="0" r="0" t="0" b="0"/>
+          <a:stretch/>
+        </p:blipFill>
         <p:spPr>
           <a:xfrm>
             <a:off x="822960" y="1965960"/>
@@ -10870,71 +10885,45 @@
           <a:prstGeom prst="rect">
             <a:avLst/>
           </a:prstGeom>
-          <a:solidFill>
-            <a:srgbClr val="ECEEFA"/>
-          </a:solidFill>
-          <a:ln/>
-        </p:spPr>
-      </p:sp>
-      <p:sp>
-        <p:nvSpPr>
-          <p:cNvPr id="7" name="Text 5"/>
-          <p:cNvSpPr txBox="1"/>
-          <p:nvPr/>
-        </p:nvSpPr>
-        <p:spPr>
-          <a:xfrm>
-            <a:off x="822960" y="1965960"/>
-            <a:ext cx="1600200" cy="1965960"/>
-          </a:xfrm>
-          <a:prstGeom prst="rect">
-            <a:avLst/>
-          </a:prstGeom>
-          <a:noFill/>
-          <a:ln/>
-        </p:spPr>
-        <p:txBody>
-          <a:bodyPr wrap="square" lIns="0" tIns="0" rIns="0" bIns="0" rtlCol="0" anchor="ctr"/>
-          <a:lstStyle/>
-          <a:p>
-            <a:pPr algn="ctr" indent="0" marL="0">
-              <a:buNone/>
-            </a:pPr>
-            <a:r>
-              <a:rPr lang="en-US" sz="4000" b="1" dirty="0">
-                <a:solidFill>
-                  <a:srgbClr val="1C2C66"/>
+        </p:spPr>
+      </p:pic>
+      <p:sp>
+        <p:nvSpPr>
+          <p:cNvPr id="7" name="Text 4"/>
+          <p:cNvSpPr txBox="1"/>
+          <p:nvPr/>
+        </p:nvSpPr>
+        <p:spPr>
+          <a:xfrm>
+            <a:off x="2651760" y="2011680"/>
+            <a:ext cx="3055468" cy="868680"/>
+          </a:xfrm>
+          <a:prstGeom prst="rect">
+            <a:avLst/>
+          </a:prstGeom>
+          <a:noFill/>
+          <a:ln/>
+        </p:spPr>
+        <p:txBody>
+          <a:bodyPr wrap="square" lIns="0" tIns="0" rIns="0" bIns="0" rtlCol="0" anchor="t"/>
+          <a:lstStyle/>
+          <a:p>
+            <a:pPr indent="0" marL="0">
+              <a:buNone/>
+            </a:pPr>
+            <a:r>
+              <a:rPr lang="en-US" sz="2000" b="1" dirty="0">
+                <a:solidFill>
+                  <a:srgbClr val="1F1D1A"/>
                 </a:solidFill>
                 <a:latin typeface="Times New Roman" pitchFamily="34" charset="0"/>
                 <a:ea typeface="Times New Roman" pitchFamily="34" charset="-122"/>
                 <a:cs typeface="Times New Roman" pitchFamily="34" charset="-120"/>
               </a:rPr>
-              <a:t>ММ</a:t>
-            </a:r>
-            <a:endParaRPr lang="en-US" sz="4000" dirty="0"/>
-          </a:p>
-        </p:txBody>
-      </p:sp>
-      <p:sp>
-        <p:nvSpPr>
-          <p:cNvPr id="8" name="Text 6"/>
-          <p:cNvSpPr txBox="1"/>
-          <p:nvPr/>
-        </p:nvSpPr>
-        <p:spPr>
-          <a:xfrm>
-            <a:off x="2651760" y="2011680"/>
-            <a:ext cx="3055468" cy="868680"/>
-          </a:xfrm>
-          <a:prstGeom prst="rect">
-            <a:avLst/>
-          </a:prstGeom>
-          <a:noFill/>
-          <a:ln/>
-        </p:spPr>
-        <p:txBody>
-          <a:bodyPr wrap="square" lIns="0" tIns="0" rIns="0" bIns="0" rtlCol="0" anchor="t"/>
-          <a:lstStyle/>
+              <a:t>Мухамедьяров</a:t>
+            </a:r>
+            <a:endParaRPr lang="en-US" sz="2000" dirty="0"/>
+          </a:p>
           <a:p>
             <a:pPr indent="0" marL="0">
               <a:buNone/>
@@ -10948,32 +10937,15 @@
                 <a:ea typeface="Times New Roman" pitchFamily="34" charset="-122"/>
                 <a:cs typeface="Times New Roman" pitchFamily="34" charset="-120"/>
               </a:rPr>
-              <a:t>Мухамедьяров</a:t>
+              <a:t>Марат Александрович</a:t>
             </a:r>
             <a:endParaRPr lang="en-US" sz="2000" dirty="0"/>
           </a:p>
-          <a:p>
-            <a:pPr indent="0" marL="0">
-              <a:buNone/>
-            </a:pPr>
-            <a:r>
-              <a:rPr lang="en-US" sz="2000" b="1" dirty="0">
-                <a:solidFill>
-                  <a:srgbClr val="1F1D1A"/>
-                </a:solidFill>
-                <a:latin typeface="Times New Roman" pitchFamily="34" charset="0"/>
-                <a:ea typeface="Times New Roman" pitchFamily="34" charset="-122"/>
-                <a:cs typeface="Times New Roman" pitchFamily="34" charset="-120"/>
-              </a:rPr>
-              <a:t>Марат Александрович</a:t>
-            </a:r>
-            <a:endParaRPr lang="en-US" sz="2000" dirty="0"/>
-          </a:p>
-        </p:txBody>
-      </p:sp>
-      <p:sp>
-        <p:nvSpPr>
-          <p:cNvPr id="9" name="Text 7"/>
+        </p:txBody>
+      </p:sp>
+      <p:sp>
+        <p:nvSpPr>
+          <p:cNvPr id="8" name="Text 5"/>
           <p:cNvSpPr txBox="1"/>
           <p:nvPr/>
         </p:nvSpPr>
@@ -11012,7 +10984,7 @@
       </p:sp>
       <p:sp>
         <p:nvSpPr>
-          <p:cNvPr id="10" name="Text 8"/>
+          <p:cNvPr id="9" name="Text 6"/>
           <p:cNvSpPr txBox="1"/>
           <p:nvPr/>
         </p:nvSpPr>
@@ -11139,7 +11111,7 @@
       </p:sp>
       <p:sp>
         <p:nvSpPr>
-          <p:cNvPr id="11" name="Shape 9"/>
+          <p:cNvPr id="10" name="Shape 7"/>
           <p:cNvSpPr/>
           <p:nvPr/>
         </p:nvSpPr>
@@ -11161,14 +11133,14 @@
       </p:sp>
       <p:pic>
         <p:nvPicPr>
-          <p:cNvPr id="12" name="Image 0" descr="/home/user/SciBox/deliverables/pitch/assets/azamat.jpg">    </p:cNvPr>
+          <p:cNvPr id="11" name="Image 1" descr="/home/user/SciBox/deliverables/pitch/assets/azamat.jpg">    </p:cNvPr>
           <p:cNvPicPr>
             <a:picLocks noChangeAspect="1"/>
           </p:cNvPicPr>
           <p:nvPr/>
         </p:nvPicPr>
         <p:blipFill>
-          <a:blip r:embed="rId1"/>
+          <a:blip r:embed="rId2"/>
           <a:srcRect l="0" r="0" t="0" b="0"/>
           <a:stretch/>
         </p:blipFill>
@@ -11184,7 +11156,7 @@
       </p:pic>
       <p:sp>
         <p:nvSpPr>
-          <p:cNvPr id="13" name="Text 10"/>
+          <p:cNvPr id="12" name="Text 8"/>
           <p:cNvSpPr txBox="1"/>
           <p:nvPr/>
         </p:nvSpPr>
@@ -11240,7 +11212,7 @@
       </p:sp>
       <p:sp>
         <p:nvSpPr>
-          <p:cNvPr id="14" name="Text 11"/>
+          <p:cNvPr id="13" name="Text 9"/>
           <p:cNvSpPr txBox="1"/>
           <p:nvPr/>
         </p:nvSpPr>
@@ -11279,7 +11251,7 @@
       </p:sp>
       <p:sp>
         <p:nvSpPr>
-          <p:cNvPr id="15" name="Text 12"/>
+          <p:cNvPr id="14" name="Text 10"/>
           <p:cNvSpPr txBox="1"/>
           <p:nvPr/>
         </p:nvSpPr>
@@ -11364,7 +11336,7 @@
       </p:sp>
       <p:sp>
         <p:nvSpPr>
-          <p:cNvPr id="16" name="Text 13"/>
+          <p:cNvPr id="15" name="Text 11"/>
           <p:cNvSpPr txBox="1"/>
           <p:nvPr/>
         </p:nvSpPr>

</xml_diff>